<commit_message>
Prepare docs and deck for the YouTube video
Remove the interview-specific parts: the guide's job-description table
becomes a capability map, 'Before the call' becomes 'Run the demo', the
personal stories section is dropped and the questions become an FAQ.
The README and walkthrough lose role and client references. The video
script gains a precision-or-recall chapter and the new supervised and
min-cut material (about 21 minutes). The deck replaces the role slide
with a 'What you will learn' map and ends with a 'Get the code' slide.
</commit_message>
<xml_diff>
--- a/er-demo/slides/customer-identity-resolution.pptx
+++ b/er-demo/slides/customer-identity-resolution.pptx
@@ -33,9 +33,10 @@
     <p:sldId id="281" r:id="rId27"/>
     <p:sldId id="282" r:id="rId28"/>
     <p:sldId id="283" r:id="rId29"/>
+    <p:sldId id="284" r:id="rId30"/>
   </p:sldIdLst>
   <p:notesMasterIdLst>
-    <p:notesMasterId r:id="rId30"/>
+    <p:notesMasterId r:id="rId31"/>
   </p:notesMasterIdLst>
   <p:sldSz cx="12192000" cy="6858000"/>
   <p:notesSz cx="6858000" cy="12192000"/>
@@ -134,7 +135,7 @@
   <p:extLst>
     <p:ext uri="{521415D9-36F7-43E2-AB2F-B90AF26B5E84}">
       <p14:sectionLst xmlns:p14="http://schemas.microsoft.com/office/powerpoint/2010/main">
-        <p14:section name="Introduction" id="{1397a0ff-dd08-aeb9-066b-7547d20a2052}">
+        <p14:section name="Introduction" id="{ce6ed520-a66e-d7cf-bf4a-1c2ceaef105a}">
           <p14:sldIdLst>
             <p14:sldId id="256"/>
             <p14:sldId id="257"/>
@@ -143,7 +144,7 @@
             <p14:sldId id="260"/>
           </p14:sldIdLst>
         </p14:section>
-        <p14:section name="Matching" id="{8751200a-cdbe-54b6-6bfd-2073ffe656ea}">
+        <p14:section name="Matching" id="{ec19b5af-1488-666c-950a-42a89ced3294}">
           <p14:sldIdLst>
             <p14:sldId id="261"/>
             <p14:sldId id="262"/>
@@ -156,7 +157,7 @@
             <p14:sldId id="269"/>
           </p14:sldIdLst>
         </p14:section>
-        <p14:section name="Graphs" id="{d00e7cc3-2f43-d205-a91e-7f50919e0712}">
+        <p14:section name="Graphs" id="{be560545-1a8b-64c1-eeeb-bcac81fe7fe8}">
           <p14:sldIdLst>
             <p14:sldId id="270"/>
             <p14:sldId id="271"/>
@@ -164,7 +165,7 @@
             <p14:sldId id="273"/>
           </p14:sldIdLst>
         </p14:section>
-        <p14:section name="Mastering" id="{48e0b491-7d85-b9d4-c550-c47ee02c09f3}">
+        <p14:section name="Mastering" id="{b4a7cccd-c7ae-230c-8214-757d6d4230f4}">
           <p14:sldIdLst>
             <p14:sldId id="274"/>
             <p14:sldId id="275"/>
@@ -172,7 +173,7 @@
             <p14:sldId id="277"/>
           </p14:sldIdLst>
         </p14:section>
-        <p14:section name="MLOps" id="{781e145b-cac6-a686-2acb-642f8270c7b4}">
+        <p14:section name="MLOps" id="{17fa8dee-1720-5740-56ad-a47e3590978e}">
           <p14:sldIdLst>
             <p14:sldId id="278"/>
             <p14:sldId id="279"/>
@@ -181,9 +182,10 @@
             <p14:sldId id="282"/>
           </p14:sldIdLst>
         </p14:section>
-        <p14:section name="Close" id="{6d36beb9-facc-95b5-3218-78e132797e9c}">
+        <p14:section name="Close" id="{4baf0c89-96fd-80fe-8a22-bb3e576e22fc}">
           <p14:sldIdLst>
             <p14:sldId id="283"/>
+            <p14:sldId id="284"/>
           </p14:sldIdLst>
         </p14:section>
       </p14:sectionLst>
@@ -3403,7 +3405,7 @@
           <a:p>
             <a:r>
               <a:rPr lang="en-US" dirty="0"/>
-              <a:t>The system-design answer for the client interview. Start by clarifying; mention a real-time path with an online feature store if needed; end on reusability and configuration.</a:t>
+              <a:t>How to build this for a real company. Start by clarifying; mention a real-time path with an online feature store if needed; end on reusability and configuration.</a:t>
             </a:r>
             <a:endParaRPr lang="en-US" dirty="0"/>
           </a:p>
@@ -3533,6 +3535,94 @@
 </p:notes>
 </file>
 
+<file path=ppt/notesSlides/notesSlide29.xml><?xml version="1.0" encoding="utf-8"?>
+<p:notes xmlns:a="http://schemas.openxmlformats.org/drawingml/2006/main" xmlns:r="http://schemas.openxmlformats.org/officeDocument/2006/relationships" xmlns:p="http://schemas.openxmlformats.org/presentationml/2006/main">
+  <p:cSld>
+    <p:spTree>
+      <p:nvGrpSpPr>
+        <p:cNvPr id="1" name=""/>
+        <p:cNvGrpSpPr/>
+        <p:nvPr/>
+      </p:nvGrpSpPr>
+      <p:grpSpPr>
+        <a:xfrm>
+          <a:off x="0" y="0"/>
+          <a:ext cx="0" cy="0"/>
+          <a:chOff x="0" y="0"/>
+          <a:chExt cx="0" cy="0"/>
+        </a:xfrm>
+      </p:grpSpPr>
+      <p:sp>
+        <p:nvSpPr>
+          <p:cNvPr id="2" name="Slide Image Placeholder 1"/>
+          <p:cNvSpPr>
+            <a:spLocks noGrp="1" noRot="1" noChangeAspect="1"/>
+          </p:cNvSpPr>
+          <p:nvPr>
+            <p:ph type="sldImg"/>
+          </p:nvPr>
+        </p:nvSpPr>
+        <p:spPr/>
+      </p:sp>
+      <p:sp>
+        <p:nvSpPr>
+          <p:cNvPr id="3" name="Notes Placeholder 2"/>
+          <p:cNvSpPr>
+            <a:spLocks noGrp="1"/>
+          </p:cNvSpPr>
+          <p:nvPr>
+            <p:ph type="body" idx="1"/>
+          </p:nvPr>
+        </p:nvSpPr>
+        <p:spPr/>
+        <p:txBody>
+          <a:bodyPr/>
+          <a:lstStyle/>
+          <a:p>
+            <a:r>
+              <a:rPr lang="en-US" dirty="0"/>
+              <a:t>The link is in the description. Clone it, run it, read the guide, and tell me in the comments what your hardest matching problem is. If this helped, subscribe for the next one.</a:t>
+            </a:r>
+            <a:endParaRPr lang="en-US" dirty="0"/>
+          </a:p>
+        </p:txBody>
+      </p:sp>
+      <p:sp>
+        <p:nvSpPr>
+          <p:cNvPr id="4" name="Slide Number Placeholder 3"/>
+          <p:cNvSpPr>
+            <a:spLocks noGrp="1"/>
+          </p:cNvSpPr>
+          <p:nvPr>
+            <p:ph type="sldNum" sz="quarter" idx="10"/>
+          </p:nvPr>
+        </p:nvSpPr>
+        <p:spPr/>
+        <p:txBody>
+          <a:bodyPr/>
+          <a:lstStyle/>
+          <a:p>
+            <a:fld id="{F7021451-1387-4CA6-816F-3879F97B5CBC}" type="slidenum">
+              <a:rPr lang="en-US"/>
+              <a:t>29</a:t>
+            </a:fld>
+            <a:endParaRPr lang="en-US"/>
+          </a:p>
+        </p:txBody>
+      </p:sp>
+    </p:spTree>
+    <p:extLst>
+      <p:ext uri="{BB962C8B-B14F-4D97-AF65-F5344CB8AC3E}">
+        <p14:creationId xmlns:p14="http://schemas.microsoft.com/office/powerpoint/2010/main" val="1024086991"/>
+      </p:ext>
+    </p:extLst>
+  </p:cSld>
+  <p:clrMapOvr>
+    <a:masterClrMapping/>
+  </p:clrMapOvr>
+</p:notes>
+</file>
+
 <file path=ppt/notesSlides/notesSlide3.xml><?xml version="1.0" encoding="utf-8"?>
 <p:notes xmlns:a="http://schemas.openxmlformats.org/drawingml/2006/main" xmlns:r="http://schemas.openxmlformats.org/officeDocument/2006/relationships" xmlns:p="http://schemas.openxmlformats.org/presentationml/2006/main">
   <p:cSld>
@@ -3579,7 +3669,7 @@
           <a:p>
             <a:r>
               <a:rPr lang="en-US" dirty="0"/>
-              <a:t>Use this as the map for the conversation. Every requirement in the job description has a script and a number behind it.</a:t>
+              <a:t>The map of the video. Every step is a script in the repository and every number on the following slides is measured on the synthetic data.</a:t>
             </a:r>
             <a:endParaRPr lang="en-US" dirty="0"/>
           </a:p>
@@ -21544,6 +21634,708 @@
 </p:sld>
 </file>
 
+<file path=ppt/slides/slide29.xml><?xml version="1.0" encoding="utf-8"?>
+<p:sld xmlns:a="http://schemas.openxmlformats.org/drawingml/2006/main" xmlns:r="http://schemas.openxmlformats.org/officeDocument/2006/relationships" xmlns:p="http://schemas.openxmlformats.org/presentationml/2006/main">
+  <p:cSld name="Slide 29">
+    <p:spTree>
+      <p:nvGrpSpPr>
+        <p:cNvPr id="1" name=""/>
+        <p:cNvGrpSpPr/>
+        <p:nvPr/>
+      </p:nvGrpSpPr>
+      <p:grpSpPr>
+        <a:xfrm>
+          <a:off x="0" y="0"/>
+          <a:ext cx="0" cy="0"/>
+          <a:chOff x="0" y="0"/>
+          <a:chExt cx="0" cy="0"/>
+        </a:xfrm>
+      </p:grpSpPr>
+      <p:sp>
+        <p:nvSpPr>
+          <p:cNvPr id="2" name="Text 0"/>
+          <p:cNvSpPr/>
+          <p:nvPr>
+            <p:ph idx="100" type="title" hasCustomPrompt="1"/>
+          </p:nvPr>
+        </p:nvSpPr>
+        <p:spPr>
+          <a:xfrm>
+            <a:off x="548640" y="365760"/>
+            <a:ext cx="11064240" cy="777240"/>
+          </a:xfrm>
+          <a:prstGeom prst="rect">
+            <a:avLst/>
+          </a:prstGeom>
+          <a:noFill/>
+          <a:ln/>
+        </p:spPr>
+        <p:txBody>
+          <a:bodyPr wrap="square" lIns="0" tIns="0" rIns="0" bIns="0" rtlCol="0" anchor="ctr"/>
+          <a:lstStyle/>
+          <a:p>
+            <a:pPr algn="l" indent="0" marL="0">
+              <a:buNone/>
+            </a:pPr>
+            <a:r>
+              <a:rPr lang="en-US" sz="3200" b="1" dirty="0">
+                <a:solidFill>
+                  <a:schemeClr val="tx2"/>
+                </a:solidFill>
+                <a:latin typeface="Cambria" pitchFamily="34" charset="0"/>
+                <a:ea typeface="Cambria" pitchFamily="34" charset="-122"/>
+                <a:cs typeface="Cambria" pitchFamily="34" charset="-120"/>
+              </a:rPr>
+              <a:t>Get the code and run it yourself</a:t>
+            </a:r>
+            <a:endParaRPr lang="en-US" sz="3200" dirty="0"/>
+          </a:p>
+        </p:txBody>
+      </p:sp>
+      <p:sp>
+        <p:nvSpPr>
+          <p:cNvPr id="3" name="Shape 1"/>
+          <p:cNvSpPr/>
+          <p:nvPr/>
+        </p:nvSpPr>
+        <p:spPr>
+          <a:xfrm>
+            <a:off x="548640" y="1371600"/>
+            <a:ext cx="11064240" cy="1463040"/>
+          </a:xfrm>
+          <a:prstGeom prst="roundRect">
+            <a:avLst>
+              <a:gd name="adj" fmla="val 7500"/>
+            </a:avLst>
+          </a:prstGeom>
+          <a:solidFill>
+            <a:schemeClr val="bg2"/>
+          </a:solidFill>
+          <a:ln/>
+        </p:spPr>
+      </p:sp>
+      <p:sp>
+        <p:nvSpPr>
+          <p:cNvPr id="4" name="Shape 2"/>
+          <p:cNvSpPr/>
+          <p:nvPr/>
+        </p:nvSpPr>
+        <p:spPr>
+          <a:xfrm>
+            <a:off x="868680" y="1783080"/>
+            <a:ext cx="685800" cy="685800"/>
+          </a:xfrm>
+          <a:prstGeom prst="ellipse">
+            <a:avLst/>
+          </a:prstGeom>
+          <a:solidFill>
+            <a:schemeClr val="tx2"/>
+          </a:solidFill>
+          <a:ln/>
+        </p:spPr>
+      </p:sp>
+      <p:pic>
+        <p:nvPicPr>
+          <p:cNvPr id="5" name="Image 0" descr="preencoded.png">    </p:cNvPr>
+          <p:cNvPicPr>
+            <a:picLocks noChangeAspect="1"/>
+          </p:cNvPicPr>
+          <p:nvPr/>
+        </p:nvPicPr>
+        <p:blipFill>
+          <a:blip r:embed="rId1"/>
+          <a:stretch>
+            <a:fillRect/>
+          </a:stretch>
+        </p:blipFill>
+        <p:spPr>
+          <a:xfrm>
+            <a:off x="1033272" y="1947672"/>
+            <a:ext cx="356616" cy="356616"/>
+          </a:xfrm>
+          <a:prstGeom prst="rect">
+            <a:avLst/>
+          </a:prstGeom>
+        </p:spPr>
+      </p:pic>
+      <p:sp>
+        <p:nvSpPr>
+          <p:cNvPr id="6" name="Text 3"/>
+          <p:cNvSpPr txBox="1"/>
+          <p:nvPr/>
+        </p:nvSpPr>
+        <p:spPr>
+          <a:xfrm>
+            <a:off x="1783080" y="1600200"/>
+            <a:ext cx="9601200" cy="640080"/>
+          </a:xfrm>
+          <a:prstGeom prst="rect">
+            <a:avLst/>
+          </a:prstGeom>
+          <a:noFill/>
+          <a:ln/>
+        </p:spPr>
+        <p:txBody>
+          <a:bodyPr wrap="square" lIns="0" tIns="0" rIns="0" bIns="0" rtlCol="0" anchor="t"/>
+          <a:lstStyle/>
+          <a:p>
+            <a:pPr indent="0" marL="0">
+              <a:buNone/>
+            </a:pPr>
+            <a:r>
+              <a:rPr lang="en-US" sz="2800" b="1" dirty="0">
+                <a:solidFill>
+                  <a:schemeClr val="tx2"/>
+                </a:solidFill>
+                <a:latin typeface="Cambria" pitchFamily="34" charset="0"/>
+                <a:ea typeface="Cambria" pitchFamily="34" charset="-122"/>
+                <a:cs typeface="Cambria" pitchFamily="34" charset="-120"/>
+              </a:rPr>
+              <a:t>github.com/olonok69/Entity-Resolution-ML</a:t>
+            </a:r>
+            <a:endParaRPr lang="en-US" sz="2800" dirty="0"/>
+          </a:p>
+        </p:txBody>
+      </p:sp>
+      <p:sp>
+        <p:nvSpPr>
+          <p:cNvPr id="7" name="Text 4"/>
+          <p:cNvSpPr txBox="1"/>
+          <p:nvPr/>
+        </p:nvSpPr>
+        <p:spPr>
+          <a:xfrm>
+            <a:off x="1783080" y="2240280"/>
+            <a:ext cx="9601200" cy="411480"/>
+          </a:xfrm>
+          <a:prstGeom prst="rect">
+            <a:avLst/>
+          </a:prstGeom>
+          <a:noFill/>
+          <a:ln/>
+        </p:spPr>
+        <p:txBody>
+          <a:bodyPr wrap="square" lIns="0" tIns="0" rIns="0" bIns="0" rtlCol="0" anchor="t"/>
+          <a:lstStyle/>
+          <a:p>
+            <a:pPr indent="0" marL="0">
+              <a:buNone/>
+            </a:pPr>
+            <a:r>
+              <a:rPr lang="en-US" sz="1600" dirty="0">
+                <a:solidFill>
+                  <a:schemeClr val="accent6"/>
+                </a:solidFill>
+              </a:rPr>
+              <a:t>Synthetic data, nine scripts, under a minute on a laptop</a:t>
+            </a:r>
+            <a:endParaRPr lang="en-US" sz="1600" dirty="0"/>
+          </a:p>
+        </p:txBody>
+      </p:sp>
+      <p:sp>
+        <p:nvSpPr>
+          <p:cNvPr id="8" name="Shape 5"/>
+          <p:cNvSpPr/>
+          <p:nvPr/>
+        </p:nvSpPr>
+        <p:spPr>
+          <a:xfrm>
+            <a:off x="548640" y="3154680"/>
+            <a:ext cx="3474720" cy="2377440"/>
+          </a:xfrm>
+          <a:prstGeom prst="roundRect">
+            <a:avLst>
+              <a:gd name="adj" fmla="val 4615"/>
+            </a:avLst>
+          </a:prstGeom>
+          <a:solidFill>
+            <a:schemeClr val="bg2"/>
+          </a:solidFill>
+          <a:ln/>
+        </p:spPr>
+      </p:sp>
+      <p:sp>
+        <p:nvSpPr>
+          <p:cNvPr id="9" name="Shape 6"/>
+          <p:cNvSpPr/>
+          <p:nvPr/>
+        </p:nvSpPr>
+        <p:spPr>
+          <a:xfrm>
+            <a:off x="822960" y="3383280"/>
+            <a:ext cx="594360" cy="594360"/>
+          </a:xfrm>
+          <a:prstGeom prst="ellipse">
+            <a:avLst/>
+          </a:prstGeom>
+          <a:solidFill>
+            <a:schemeClr val="accent1"/>
+          </a:solidFill>
+          <a:ln/>
+        </p:spPr>
+      </p:sp>
+      <p:pic>
+        <p:nvPicPr>
+          <p:cNvPr id="10" name="Image 1" descr="preencoded.png">    </p:cNvPr>
+          <p:cNvPicPr>
+            <a:picLocks noChangeAspect="1"/>
+          </p:cNvPicPr>
+          <p:nvPr/>
+        </p:nvPicPr>
+        <p:blipFill>
+          <a:blip r:embed="rId2"/>
+          <a:stretch>
+            <a:fillRect/>
+          </a:stretch>
+        </p:blipFill>
+        <p:spPr>
+          <a:xfrm>
+            <a:off x="965606" y="3525926"/>
+            <a:ext cx="309067" cy="309067"/>
+          </a:xfrm>
+          <a:prstGeom prst="rect">
+            <a:avLst/>
+          </a:prstGeom>
+        </p:spPr>
+      </p:pic>
+      <p:sp>
+        <p:nvSpPr>
+          <p:cNvPr id="11" name="Text 7"/>
+          <p:cNvSpPr txBox="1"/>
+          <p:nvPr/>
+        </p:nvSpPr>
+        <p:spPr>
+          <a:xfrm>
+            <a:off x="822960" y="4114800"/>
+            <a:ext cx="2926080" cy="411480"/>
+          </a:xfrm>
+          <a:prstGeom prst="rect">
+            <a:avLst/>
+          </a:prstGeom>
+          <a:noFill/>
+          <a:ln/>
+        </p:spPr>
+        <p:txBody>
+          <a:bodyPr wrap="square" lIns="0" tIns="0" rIns="0" bIns="0" rtlCol="0" anchor="t"/>
+          <a:lstStyle/>
+          <a:p>
+            <a:pPr indent="0" marL="0">
+              <a:buNone/>
+            </a:pPr>
+            <a:r>
+              <a:rPr lang="en-US" sz="1900" b="1" dirty="0">
+                <a:solidFill>
+                  <a:schemeClr val="tx2"/>
+                </a:solidFill>
+              </a:rPr>
+              <a:t>Run</a:t>
+            </a:r>
+            <a:endParaRPr lang="en-US" sz="1900" dirty="0"/>
+          </a:p>
+        </p:txBody>
+      </p:sp>
+      <p:sp>
+        <p:nvSpPr>
+          <p:cNvPr id="12" name="Text 8"/>
+          <p:cNvSpPr txBox="1"/>
+          <p:nvPr/>
+        </p:nvSpPr>
+        <p:spPr>
+          <a:xfrm>
+            <a:off x="822960" y="4572000"/>
+            <a:ext cx="2971800" cy="822960"/>
+          </a:xfrm>
+          <a:prstGeom prst="rect">
+            <a:avLst/>
+          </a:prstGeom>
+          <a:noFill/>
+          <a:ln/>
+        </p:spPr>
+        <p:txBody>
+          <a:bodyPr wrap="square" lIns="0" tIns="0" rIns="0" bIns="0" rtlCol="0" anchor="t"/>
+          <a:lstStyle/>
+          <a:p>
+            <a:pPr indent="0" marL="0">
+              <a:buNone/>
+            </a:pPr>
+            <a:r>
+              <a:rPr lang="en-US" sz="1400" dirty="0">
+                <a:solidFill>
+                  <a:schemeClr val="tx1"/>
+                </a:solidFill>
+              </a:rPr>
+              <a:t>bash run_all.sh, or the PowerShell steps in the guide</a:t>
+            </a:r>
+            <a:endParaRPr lang="en-US" sz="1400" dirty="0"/>
+          </a:p>
+        </p:txBody>
+      </p:sp>
+      <p:sp>
+        <p:nvSpPr>
+          <p:cNvPr id="13" name="Shape 9"/>
+          <p:cNvSpPr/>
+          <p:nvPr/>
+        </p:nvSpPr>
+        <p:spPr>
+          <a:xfrm>
+            <a:off x="4297680" y="3154680"/>
+            <a:ext cx="3474720" cy="2377440"/>
+          </a:xfrm>
+          <a:prstGeom prst="roundRect">
+            <a:avLst>
+              <a:gd name="adj" fmla="val 4615"/>
+            </a:avLst>
+          </a:prstGeom>
+          <a:solidFill>
+            <a:schemeClr val="bg2"/>
+          </a:solidFill>
+          <a:ln/>
+        </p:spPr>
+      </p:sp>
+      <p:sp>
+        <p:nvSpPr>
+          <p:cNvPr id="14" name="Shape 10"/>
+          <p:cNvSpPr/>
+          <p:nvPr/>
+        </p:nvSpPr>
+        <p:spPr>
+          <a:xfrm>
+            <a:off x="4572000" y="3383280"/>
+            <a:ext cx="594360" cy="594360"/>
+          </a:xfrm>
+          <a:prstGeom prst="ellipse">
+            <a:avLst/>
+          </a:prstGeom>
+          <a:solidFill>
+            <a:schemeClr val="accent1"/>
+          </a:solidFill>
+          <a:ln/>
+        </p:spPr>
+      </p:sp>
+      <p:pic>
+        <p:nvPicPr>
+          <p:cNvPr id="15" name="Image 2" descr="preencoded.png">    </p:cNvPr>
+          <p:cNvPicPr>
+            <a:picLocks noChangeAspect="1"/>
+          </p:cNvPicPr>
+          <p:nvPr/>
+        </p:nvPicPr>
+        <p:blipFill>
+          <a:blip r:embed="rId3"/>
+          <a:stretch>
+            <a:fillRect/>
+          </a:stretch>
+        </p:blipFill>
+        <p:spPr>
+          <a:xfrm>
+            <a:off x="4714646" y="3525926"/>
+            <a:ext cx="309067" cy="309067"/>
+          </a:xfrm>
+          <a:prstGeom prst="rect">
+            <a:avLst/>
+          </a:prstGeom>
+        </p:spPr>
+      </p:pic>
+      <p:sp>
+        <p:nvSpPr>
+          <p:cNvPr id="16" name="Text 11"/>
+          <p:cNvSpPr txBox="1"/>
+          <p:nvPr/>
+        </p:nvSpPr>
+        <p:spPr>
+          <a:xfrm>
+            <a:off x="4572000" y="4114800"/>
+            <a:ext cx="2926080" cy="411480"/>
+          </a:xfrm>
+          <a:prstGeom prst="rect">
+            <a:avLst/>
+          </a:prstGeom>
+          <a:noFill/>
+          <a:ln/>
+        </p:spPr>
+        <p:txBody>
+          <a:bodyPr wrap="square" lIns="0" tIns="0" rIns="0" bIns="0" rtlCol="0" anchor="t"/>
+          <a:lstStyle/>
+          <a:p>
+            <a:pPr indent="0" marL="0">
+              <a:buNone/>
+            </a:pPr>
+            <a:r>
+              <a:rPr lang="en-US" sz="1900" b="1" dirty="0">
+                <a:solidFill>
+                  <a:schemeClr val="tx2"/>
+                </a:solidFill>
+              </a:rPr>
+              <a:t>Learn</a:t>
+            </a:r>
+            <a:endParaRPr lang="en-US" sz="1900" dirty="0"/>
+          </a:p>
+        </p:txBody>
+      </p:sp>
+      <p:sp>
+        <p:nvSpPr>
+          <p:cNvPr id="17" name="Text 12"/>
+          <p:cNvSpPr txBox="1"/>
+          <p:nvPr/>
+        </p:nvSpPr>
+        <p:spPr>
+          <a:xfrm>
+            <a:off x="4572000" y="4572000"/>
+            <a:ext cx="2971800" cy="822960"/>
+          </a:xfrm>
+          <a:prstGeom prst="rect">
+            <a:avLst/>
+          </a:prstGeom>
+          <a:noFill/>
+          <a:ln/>
+        </p:spPr>
+        <p:txBody>
+          <a:bodyPr wrap="square" lIns="0" tIns="0" rIns="0" bIns="0" rtlCol="0" anchor="t"/>
+          <a:lstStyle/>
+          <a:p>
+            <a:pPr indent="0" marL="0">
+              <a:buNone/>
+            </a:pPr>
+            <a:r>
+              <a:rPr lang="en-US" sz="1400" dirty="0">
+                <a:solidFill>
+                  <a:schemeClr val="tx1"/>
+                </a:solidFill>
+              </a:rPr>
+              <a:t>DEMO_GUIDE.md: every technique step by step with these numbers</a:t>
+            </a:r>
+            <a:endParaRPr lang="en-US" sz="1400" dirty="0"/>
+          </a:p>
+        </p:txBody>
+      </p:sp>
+      <p:sp>
+        <p:nvSpPr>
+          <p:cNvPr id="18" name="Shape 13"/>
+          <p:cNvSpPr/>
+          <p:nvPr/>
+        </p:nvSpPr>
+        <p:spPr>
+          <a:xfrm>
+            <a:off x="8046720" y="3154680"/>
+            <a:ext cx="3474720" cy="2377440"/>
+          </a:xfrm>
+          <a:prstGeom prst="roundRect">
+            <a:avLst>
+              <a:gd name="adj" fmla="val 4615"/>
+            </a:avLst>
+          </a:prstGeom>
+          <a:solidFill>
+            <a:schemeClr val="bg2"/>
+          </a:solidFill>
+          <a:ln/>
+        </p:spPr>
+      </p:sp>
+      <p:sp>
+        <p:nvSpPr>
+          <p:cNvPr id="19" name="Shape 14"/>
+          <p:cNvSpPr/>
+          <p:nvPr/>
+        </p:nvSpPr>
+        <p:spPr>
+          <a:xfrm>
+            <a:off x="8321040" y="3383280"/>
+            <a:ext cx="594360" cy="594360"/>
+          </a:xfrm>
+          <a:prstGeom prst="ellipse">
+            <a:avLst/>
+          </a:prstGeom>
+          <a:solidFill>
+            <a:schemeClr val="accent2"/>
+          </a:solidFill>
+          <a:ln/>
+        </p:spPr>
+      </p:sp>
+      <p:pic>
+        <p:nvPicPr>
+          <p:cNvPr id="20" name="Image 3" descr="preencoded.png">    </p:cNvPr>
+          <p:cNvPicPr>
+            <a:picLocks noChangeAspect="1"/>
+          </p:cNvPicPr>
+          <p:nvPr/>
+        </p:nvPicPr>
+        <p:blipFill>
+          <a:blip r:embed="rId4"/>
+          <a:stretch>
+            <a:fillRect/>
+          </a:stretch>
+        </p:blipFill>
+        <p:spPr>
+          <a:xfrm>
+            <a:off x="8463686" y="3525926"/>
+            <a:ext cx="309067" cy="309067"/>
+          </a:xfrm>
+          <a:prstGeom prst="rect">
+            <a:avLst/>
+          </a:prstGeom>
+        </p:spPr>
+      </p:pic>
+      <p:sp>
+        <p:nvSpPr>
+          <p:cNvPr id="21" name="Text 15"/>
+          <p:cNvSpPr txBox="1"/>
+          <p:nvPr/>
+        </p:nvSpPr>
+        <p:spPr>
+          <a:xfrm>
+            <a:off x="8321040" y="4114800"/>
+            <a:ext cx="2926080" cy="411480"/>
+          </a:xfrm>
+          <a:prstGeom prst="rect">
+            <a:avLst/>
+          </a:prstGeom>
+          <a:noFill/>
+          <a:ln/>
+        </p:spPr>
+        <p:txBody>
+          <a:bodyPr wrap="square" lIns="0" tIns="0" rIns="0" bIns="0" rtlCol="0" anchor="t"/>
+          <a:lstStyle/>
+          <a:p>
+            <a:pPr indent="0" marL="0">
+              <a:buNone/>
+            </a:pPr>
+            <a:r>
+              <a:rPr lang="en-US" sz="1900" b="1" dirty="0">
+                <a:solidFill>
+                  <a:schemeClr val="tx2"/>
+                </a:solidFill>
+              </a:rPr>
+              <a:t>Tell me</a:t>
+            </a:r>
+            <a:endParaRPr lang="en-US" sz="1900" dirty="0"/>
+          </a:p>
+        </p:txBody>
+      </p:sp>
+      <p:sp>
+        <p:nvSpPr>
+          <p:cNvPr id="22" name="Text 16"/>
+          <p:cNvSpPr txBox="1"/>
+          <p:nvPr/>
+        </p:nvSpPr>
+        <p:spPr>
+          <a:xfrm>
+            <a:off x="8321040" y="4572000"/>
+            <a:ext cx="2971800" cy="822960"/>
+          </a:xfrm>
+          <a:prstGeom prst="rect">
+            <a:avLst/>
+          </a:prstGeom>
+          <a:noFill/>
+          <a:ln/>
+        </p:spPr>
+        <p:txBody>
+          <a:bodyPr wrap="square" lIns="0" tIns="0" rIns="0" bIns="0" rtlCol="0" anchor="t"/>
+          <a:lstStyle/>
+          <a:p>
+            <a:pPr indent="0" marL="0">
+              <a:buNone/>
+            </a:pPr>
+            <a:r>
+              <a:rPr lang="en-US" sz="1400" dirty="0">
+                <a:solidFill>
+                  <a:schemeClr val="tx1"/>
+                </a:solidFill>
+              </a:rPr>
+              <a:t>Your hardest matching problem, in the comments</a:t>
+            </a:r>
+            <a:endParaRPr lang="en-US" sz="1400" dirty="0"/>
+          </a:p>
+        </p:txBody>
+      </p:sp>
+      <p:sp>
+        <p:nvSpPr>
+          <p:cNvPr id="23" name="Text 17"/>
+          <p:cNvSpPr txBox="1"/>
+          <p:nvPr/>
+        </p:nvSpPr>
+        <p:spPr>
+          <a:xfrm>
+            <a:off x="548640" y="5715000"/>
+            <a:ext cx="11064240" cy="365760"/>
+          </a:xfrm>
+          <a:prstGeom prst="rect">
+            <a:avLst/>
+          </a:prstGeom>
+          <a:noFill/>
+          <a:ln/>
+        </p:spPr>
+        <p:txBody>
+          <a:bodyPr wrap="square" lIns="0" tIns="0" rIns="0" bIns="0" rtlCol="0" anchor="t"/>
+          <a:lstStyle/>
+          <a:p>
+            <a:pPr indent="0" marL="0">
+              <a:buNone/>
+            </a:pPr>
+            <a:r>
+              <a:rPr lang="en-US" sz="1300" dirty="0">
+                <a:solidFill>
+                  <a:schemeClr val="accent6"/>
+                </a:solidFill>
+              </a:rPr>
+              <a:t>All open source: Splink (MIT), rapidfuzz, recordlinkage, networkx, DuckDB, scikit-learn.</a:t>
+            </a:r>
+            <a:endParaRPr lang="en-US" sz="1300" dirty="0"/>
+          </a:p>
+        </p:txBody>
+      </p:sp>
+      <p:sp>
+        <p:nvSpPr>
+          <p:cNvPr id="25" name="Slide Number Placeholder 0"/>
+          <p:cNvSpPr>
+            <a:spLocks noGrp="1"/>
+          </p:cNvSpPr>
+          <p:nvPr>
+            <p:ph type="sldNum" sz="quarter" idx="4294967295"/>
+          </p:nvPr>
+        </p:nvSpPr>
+        <p:spPr>
+          <a:xfrm>
+            <a:off x="11155680" y="6355080"/>
+            <a:ext cx="457200" cy="274320"/>
+          </a:xfrm>
+          <a:prstGeom prst="rect">
+            <a:avLst/>
+          </a:prstGeom>
+          <a:extLst>
+            <a:ext uri="{C572A759-6A51-4108-AA02-DFA0A04FC94B}">
+              <ma14:wrappingTextBoxFlag xmlns:ma14="http://schemas.microsoft.com/office/mac/drawingml/2011/main" val="0"/>
+            </a:ext>
+          </a:extLst>
+        </p:spPr>
+        <p:txBody>
+          <a:bodyPr/>
+          <a:lstStyle>
+            <a:lvl1pPr>
+              <a:defRPr sz="1000">
+                <a:solidFill>
+                  <a:schemeClr val="accent6"/>
+                </a:solidFill>
+              </a:defRPr>
+            </a:lvl1pPr>
+          </a:lstStyle>
+          <a:p>
+            <a:pPr algn="r"/>
+            <a:fld id="{F7021451-1387-4CA6-816F-3879F97B5CBC}" type="slidenum">
+              <a:rPr b="0" lang="en-US"/>
+              <a:t>29</a:t>
+            </a:fld>
+            <a:endParaRPr lang="en-US"/>
+          </a:p>
+        </p:txBody>
+      </p:sp>
+    </p:spTree>
+  </p:cSld>
+  <p:clrMapOvr>
+    <a:masterClrMapping/>
+  </p:clrMapOvr>
+</p:sld>
+</file>
+
 <file path=ppt/slides/slide3.xml><?xml version="1.0" encoding="utf-8"?>
 <p:sld xmlns:a="http://schemas.openxmlformats.org/drawingml/2006/main" xmlns:r="http://schemas.openxmlformats.org/officeDocument/2006/relationships" xmlns:p="http://schemas.openxmlformats.org/presentationml/2006/main">
   <p:cSld name="Slide 3">
@@ -21596,7 +22388,7 @@
                 <a:ea typeface="Cambria" pitchFamily="34" charset="-122"/>
                 <a:cs typeface="Cambria" pitchFamily="34" charset="-120"/>
               </a:rPr>
-              <a:t>What the role asks for, and where the demo shows it</a:t>
+              <a:t>What you will learn in this video</a:t>
             </a:r>
             <a:endParaRPr lang="en-US" sz="3200" dirty="0"/>
           </a:p>
@@ -21698,7 +22490,7 @@
                   <a:schemeClr val="tx2"/>
                 </a:solidFill>
               </a:rPr>
-              <a:t>Graph-based ER</a:t>
+              <a:t>Standardise and block</a:t>
             </a:r>
             <a:endParaRPr lang="en-US" sz="1600" dirty="0"/>
           </a:p>
@@ -21734,7 +22526,7 @@
                   <a:schemeClr val="accent6"/>
                 </a:solidFill>
               </a:rPr>
-              <a:t>Record graph, cannot-link, min-cut repair</a:t>
+              <a:t>Clean the fields, compare 0.02% of pairs</a:t>
             </a:r>
             <a:endParaRPr lang="en-US" sz="1400" dirty="0"/>
           </a:p>
@@ -21836,7 +22628,7 @@
                   <a:schemeClr val="tx2"/>
                 </a:solidFill>
               </a:rPr>
-              <a:t>Record linkage, fuzzy</a:t>
+              <a:t>Rules and fuzzy matching</a:t>
             </a:r>
             <a:endParaRPr lang="en-US" sz="1600" dirty="0"/>
           </a:p>
@@ -21872,7 +22664,7 @@
                   <a:schemeClr val="accent6"/>
                 </a:solidFill>
               </a:rPr>
-              <a:t>rapidfuzz rules, Splink Fellegi-Sunter</a:t>
+              <a:t>rapidfuzz scores, thresholds, Union-Find</a:t>
             </a:r>
             <a:endParaRPr lang="en-US" sz="1400" dirty="0"/>
           </a:p>
@@ -21974,7 +22766,7 @@
                   <a:schemeClr val="tx2"/>
                 </a:solidFill>
               </a:rPr>
-              <a:t>ML where rules fail</a:t>
+              <a:t>Splink, Fellegi-Sunter</a:t>
             </a:r>
             <a:endParaRPr lang="en-US" sz="1600" dirty="0"/>
           </a:p>
@@ -22010,7 +22802,7 @@
                   <a:schemeClr val="accent6"/>
                 </a:solidFill>
               </a:rPr>
-              <a:t>Unsupervised EM, supervised classifier</a:t>
+              <a:t>m, u and bits of evidence, no labels</a:t>
             </a:r>
             <a:endParaRPr lang="en-US" sz="1400" dirty="0"/>
           </a:p>
@@ -22112,7 +22904,7 @@
                   <a:schemeClr val="tx2"/>
                 </a:solidFill>
               </a:rPr>
-              <a:t>Customer spine</a:t>
+              <a:t>Supervised ML</a:t>
             </a:r>
             <a:endParaRPr lang="en-US" sz="1600" dirty="0"/>
           </a:p>
@@ -22148,7 +22940,7 @@
                   <a:schemeClr val="accent6"/>
                 </a:solidFill>
               </a:rPr>
-              <a:t>Household → customer → source hierarchy</a:t>
+              <a:t>Pair features, labels, calibration</a:t>
             </a:r>
             <a:endParaRPr lang="en-US" sz="1400" dirty="0"/>
           </a:p>
@@ -22250,7 +23042,7 @@
                   <a:schemeClr val="tx2"/>
                 </a:solidFill>
               </a:rPr>
-              <a:t>Identity drift</a:t>
+              <a:t>Precision or recall</a:t>
             </a:r>
             <a:endParaRPr lang="en-US" sz="1600" dirty="0"/>
           </a:p>
@@ -22286,7 +23078,7 @@
                   <a:schemeClr val="accent6"/>
                 </a:solidFill>
               </a:rPr>
-              <a:t>Carry-forward ids: 56% → 0.2% drift</a:t>
+              <a:t>Price each error, use two thresholds</a:t>
             </a:r>
             <a:endParaRPr lang="en-US" sz="1400" dirty="0"/>
           </a:p>
@@ -22388,7 +23180,7 @@
                   <a:schemeClr val="tx2"/>
                 </a:solidFill>
               </a:rPr>
-              <a:t>Quality metrics</a:t>
+              <a:t>Graphs</a:t>
             </a:r>
             <a:endParaRPr lang="en-US" sz="1600" dirty="0"/>
           </a:p>
@@ -22424,7 +23216,7 @@
                   <a:schemeClr val="accent6"/>
                 </a:solidFill>
               </a:rPr>
-              <a:t>Pairwise, B-cubed, calibration, PSI</a:t>
+              <a:t>Chaining, cannot-link rules, minimum cut</a:t>
             </a:r>
             <a:endParaRPr lang="en-US" sz="1400" dirty="0"/>
           </a:p>
@@ -22526,7 +23318,7 @@
                   <a:schemeClr val="tx2"/>
                 </a:solidFill>
               </a:rPr>
-              <a:t>Golden Layer</a:t>
+              <a:t>MDM</a:t>
             </a:r>
             <a:endParaRPr lang="en-US" sz="1600" dirty="0"/>
           </a:p>
@@ -22562,7 +23354,7 @@
                   <a:schemeClr val="accent6"/>
                 </a:solidFill>
               </a:rPr>
-              <a:t>Spine published only when contracts pass</a:t>
+              <a:t>Golden record, survivorship, stewardship</a:t>
             </a:r>
             <a:endParaRPr lang="en-US" sz="1400" dirty="0"/>
           </a:p>
@@ -22664,7 +23456,7 @@
                   <a:schemeClr val="tx2"/>
                 </a:solidFill>
               </a:rPr>
-              <a:t>MLOps</a:t>
+              <a:t>Customer spine</a:t>
             </a:r>
             <a:endParaRPr lang="en-US" sz="1600" dirty="0"/>
           </a:p>
@@ -22700,7 +23492,7 @@
                   <a:schemeClr val="accent6"/>
                 </a:solidFill>
               </a:rPr>
-              <a:t>Registry, promotion gate, monitoring</a:t>
+              <a:t>Household → customer → source, contracts</a:t>
             </a:r>
             <a:endParaRPr lang="en-US" sz="1400" dirty="0"/>
           </a:p>
@@ -22802,7 +23594,7 @@
                   <a:schemeClr val="tx2"/>
                 </a:solidFill>
               </a:rPr>
-              <a:t>Feature store</a:t>
+              <a:t>Identity drift</a:t>
             </a:r>
             <a:endParaRPr lang="en-US" sz="1600" dirty="0"/>
           </a:p>
@@ -22838,7 +23630,7 @@
                   <a:schemeClr val="accent6"/>
                 </a:solidFill>
               </a:rPr>
-              <a:t>Versioned features, no training/serving skew</a:t>
+              <a:t>Keep ids stable: 56% → 0.2% change</a:t>
             </a:r>
             <a:endParaRPr lang="en-US" sz="1400" dirty="0"/>
           </a:p>
@@ -22940,7 +23732,7 @@
                   <a:schemeClr val="tx2"/>
                 </a:solidFill>
               </a:rPr>
-              <a:t>MDM</a:t>
+              <a:t>MLOps</a:t>
             </a:r>
             <a:endParaRPr lang="en-US" sz="1600" dirty="0"/>
           </a:p>
@@ -22976,7 +23768,7 @@
                   <a:schemeClr val="accent6"/>
                 </a:solidFill>
               </a:rPr>
-              <a:t>Survivorship, provenance, stewardship</a:t>
+              <a:t>Feature store, registry, monitoring</a:t>
             </a:r>
             <a:endParaRPr lang="en-US" sz="1400" dirty="0"/>
           </a:p>

</xml_diff>